<commit_message>
Refactor scheduling UI and backend workflow handling
</commit_message>
<xml_diff>
--- a/docs/highlights_deck/paichan_editable.pptx
+++ b/docs/highlights_deck/paichan_editable.pptx
@@ -3708,20 +3708,20 @@
         </p:nvSpPr>
         <p:spPr>
           <a:xfrm>
-            <a:off x="640080" y="3703320"/>
-            <a:ext cx="5029200" cy="402336"/>
+            <a:off x="640080" y="3520440"/>
+            <a:ext cx="1417320" cy="384048"/>
           </a:xfrm>
           <a:prstGeom prst="roundRect">
             <a:avLst>
-              <a:gd name="adj" fmla="val 22000"/>
+              <a:gd name="adj" fmla="val 50000"/>
             </a:avLst>
           </a:prstGeom>
           <a:solidFill>
             <a:srgbClr val="FFFFFF"/>
           </a:solidFill>
-          <a:ln w="12700">
+          <a:ln w="19050">
             <a:solidFill>
-              <a:srgbClr val="D8DBE0"/>
+              <a:srgbClr val="0071E3"/>
             </a:solidFill>
           </a:ln>
           <a:effectLst/>
@@ -3741,78 +3741,226 @@
           </a:fontRef>
         </p:style>
         <p:txBody>
-          <a:bodyPr rtlCol="0" anchor="ctr" wrap="square" lIns="164592" rIns="54864" tIns="18288" bIns="18288"/>
-          <a:lstStyle/>
-          <a:p>
-            <a:pPr algn="l"/>
-            <a:r>
-              <a:rPr sz="1300" b="1">
-                <a:solidFill>
-                  <a:srgbClr val="1D1D1F"/>
+          <a:bodyPr rtlCol="0" anchor="ctr" wrap="square" lIns="54864" rIns="54864" tIns="18288" bIns="18288"/>
+          <a:lstStyle/>
+          <a:p>
+            <a:pPr algn="ctr"/>
+            <a:r>
+              <a:rPr sz="1200" b="1">
+                <a:solidFill>
+                  <a:srgbClr val="0071E3"/>
                 </a:solidFill>
                 <a:latin typeface="PingFang SC"/>
                 <a:ea typeface="PingFang SC"/>
                 <a:cs typeface="PingFang SC"/>
               </a:rPr>
-              <a:t>Media Task A</a:t>
-            </a:r>
-          </a:p>
-        </p:txBody>
-      </p:sp>
-      <p:sp>
-        <p:nvSpPr>
-          <p:cNvPr id="16" name="Oval 15"/>
-          <p:cNvSpPr/>
-          <p:nvPr/>
-        </p:nvSpPr>
-        <p:spPr>
-          <a:xfrm>
-            <a:off x="4434840" y="3858768"/>
-            <a:ext cx="91440" cy="91440"/>
-          </a:xfrm>
-          <a:prstGeom prst="ellipse">
-            <a:avLst/>
-          </a:prstGeom>
-          <a:solidFill>
-            <a:srgbClr val="C98A2B"/>
-          </a:solidFill>
-          <a:ln>
-            <a:noFill/>
-          </a:ln>
-          <a:effectLst/>
-        </p:spPr>
-        <p:style>
-          <a:lnRef idx="1">
-            <a:schemeClr val="accent1"/>
-          </a:lnRef>
-          <a:fillRef idx="3">
-            <a:schemeClr val="accent1"/>
-          </a:fillRef>
-          <a:effectRef idx="2">
-            <a:schemeClr val="accent1"/>
-          </a:effectRef>
-          <a:fontRef idx="minor">
-            <a:schemeClr val="lt1"/>
-          </a:fontRef>
-        </p:style>
-        <p:txBody>
-          <a:bodyPr rtlCol="0" anchor="ctr"/>
+              <a:t>工艺模版</a:t>
+            </a:r>
+          </a:p>
+        </p:txBody>
+      </p:sp>
+      <p:cxnSp>
+        <p:nvCxnSpPr>
+          <p:cNvPr id="16" name="Connector 15"/>
+          <p:cNvCxnSpPr/>
+          <p:nvPr/>
+        </p:nvCxnSpPr>
+        <p:spPr>
+          <a:xfrm>
+            <a:off x="2093976" y="3712464"/>
+            <a:ext cx="173736" cy="0"/>
+          </a:xfrm>
+          <a:prstGeom prst="line">
+            <a:avLst/>
+          </a:prstGeom>
+          <a:ln w="16510">
+            <a:solidFill>
+              <a:srgbClr val="86868B"/>
+            </a:solidFill>
+            <a:tailEnd type="triangle" w="med" len="med"/>
+          </a:ln>
+          <a:effectLst/>
+        </p:spPr>
+        <p:style>
+          <a:lnRef idx="2">
+            <a:schemeClr val="accent1"/>
+          </a:lnRef>
+          <a:fillRef idx="0">
+            <a:schemeClr val="accent1"/>
+          </a:fillRef>
+          <a:effectRef idx="1">
+            <a:schemeClr val="accent1"/>
+          </a:effectRef>
+          <a:fontRef idx="minor">
+            <a:schemeClr val="tx1"/>
+          </a:fontRef>
+        </p:style>
+      </p:cxnSp>
+      <p:sp>
+        <p:nvSpPr>
+          <p:cNvPr id="17" name="Rounded Rectangle 16"/>
+          <p:cNvSpPr/>
+          <p:nvPr/>
+        </p:nvSpPr>
+        <p:spPr>
+          <a:xfrm>
+            <a:off x="2304288" y="3520440"/>
+            <a:ext cx="1417320" cy="384048"/>
+          </a:xfrm>
+          <a:prstGeom prst="roundRect">
+            <a:avLst>
+              <a:gd name="adj" fmla="val 50000"/>
+            </a:avLst>
+          </a:prstGeom>
+          <a:solidFill>
+            <a:srgbClr val="FFFFFF"/>
+          </a:solidFill>
+          <a:ln w="19050">
+            <a:solidFill>
+              <a:srgbClr val="06A59A"/>
+            </a:solidFill>
+          </a:ln>
+          <a:effectLst/>
+        </p:spPr>
+        <p:style>
+          <a:lnRef idx="1">
+            <a:schemeClr val="accent1"/>
+          </a:lnRef>
+          <a:fillRef idx="3">
+            <a:schemeClr val="accent1"/>
+          </a:fillRef>
+          <a:effectRef idx="2">
+            <a:schemeClr val="accent1"/>
+          </a:effectRef>
+          <a:fontRef idx="minor">
+            <a:schemeClr val="lt1"/>
+          </a:fontRef>
+        </p:style>
+        <p:txBody>
+          <a:bodyPr rtlCol="0" anchor="ctr" wrap="square" lIns="54864" rIns="54864" tIns="18288" bIns="18288"/>
           <a:lstStyle/>
           <a:p>
             <a:pPr algn="ctr"/>
-          </a:p>
-        </p:txBody>
-      </p:sp>
-      <p:sp>
-        <p:nvSpPr>
-          <p:cNvPr id="17" name="TextBox 16"/>
+            <a:r>
+              <a:rPr sz="1200" b="1">
+                <a:solidFill>
+                  <a:srgbClr val="06A59A"/>
+                </a:solidFill>
+                <a:latin typeface="PingFang SC"/>
+                <a:ea typeface="PingFang SC"/>
+                <a:cs typeface="PingFang SC"/>
+              </a:rPr>
+              <a:t>工艺阶段</a:t>
+            </a:r>
+          </a:p>
+        </p:txBody>
+      </p:sp>
+      <p:cxnSp>
+        <p:nvCxnSpPr>
+          <p:cNvPr id="18" name="Connector 17"/>
+          <p:cNvCxnSpPr/>
+          <p:nvPr/>
+        </p:nvCxnSpPr>
+        <p:spPr>
+          <a:xfrm>
+            <a:off x="3758184" y="3712464"/>
+            <a:ext cx="173736" cy="0"/>
+          </a:xfrm>
+          <a:prstGeom prst="line">
+            <a:avLst/>
+          </a:prstGeom>
+          <a:ln w="16510">
+            <a:solidFill>
+              <a:srgbClr val="86868B"/>
+            </a:solidFill>
+            <a:tailEnd type="triangle" w="med" len="med"/>
+          </a:ln>
+          <a:effectLst/>
+        </p:spPr>
+        <p:style>
+          <a:lnRef idx="2">
+            <a:schemeClr val="accent1"/>
+          </a:lnRef>
+          <a:fillRef idx="0">
+            <a:schemeClr val="accent1"/>
+          </a:fillRef>
+          <a:effectRef idx="1">
+            <a:schemeClr val="accent1"/>
+          </a:effectRef>
+          <a:fontRef idx="minor">
+            <a:schemeClr val="tx1"/>
+          </a:fontRef>
+        </p:style>
+      </p:cxnSp>
+      <p:sp>
+        <p:nvSpPr>
+          <p:cNvPr id="19" name="Rounded Rectangle 18"/>
+          <p:cNvSpPr/>
+          <p:nvPr/>
+        </p:nvSpPr>
+        <p:spPr>
+          <a:xfrm>
+            <a:off x="3968496" y="3520440"/>
+            <a:ext cx="1417320" cy="384048"/>
+          </a:xfrm>
+          <a:prstGeom prst="roundRect">
+            <a:avLst>
+              <a:gd name="adj" fmla="val 50000"/>
+            </a:avLst>
+          </a:prstGeom>
+          <a:solidFill>
+            <a:srgbClr val="FFFFFF"/>
+          </a:solidFill>
+          <a:ln w="19050">
+            <a:solidFill>
+              <a:srgbClr val="34A06B"/>
+            </a:solidFill>
+          </a:ln>
+          <a:effectLst/>
+        </p:spPr>
+        <p:style>
+          <a:lnRef idx="1">
+            <a:schemeClr val="accent1"/>
+          </a:lnRef>
+          <a:fillRef idx="3">
+            <a:schemeClr val="accent1"/>
+          </a:fillRef>
+          <a:effectRef idx="2">
+            <a:schemeClr val="accent1"/>
+          </a:effectRef>
+          <a:fontRef idx="minor">
+            <a:schemeClr val="lt1"/>
+          </a:fontRef>
+        </p:style>
+        <p:txBody>
+          <a:bodyPr rtlCol="0" anchor="ctr" wrap="square" lIns="54864" rIns="54864" tIns="18288" bIns="18288"/>
+          <a:lstStyle/>
+          <a:p>
+            <a:pPr algn="ctr"/>
+            <a:r>
+              <a:rPr sz="1200" b="1">
+                <a:solidFill>
+                  <a:srgbClr val="34A06B"/>
+                </a:solidFill>
+                <a:latin typeface="PingFang SC"/>
+                <a:ea typeface="PingFang SC"/>
+                <a:cs typeface="PingFang SC"/>
+              </a:rPr>
+              <a:t>标准操作</a:t>
+            </a:r>
+          </a:p>
+        </p:txBody>
+      </p:sp>
+      <p:sp>
+        <p:nvSpPr>
+          <p:cNvPr id="20" name="TextBox 19"/>
           <p:cNvSpPr txBox="1"/>
           <p:nvPr/>
         </p:nvSpPr>
         <p:spPr>
           <a:xfrm>
-            <a:off x="4590288" y="3781044"/>
-            <a:ext cx="960120" cy="256032"/>
+            <a:off x="640080" y="4059936"/>
+            <a:ext cx="2743200" cy="749808"/>
           </a:xfrm>
           <a:prstGeom prst="rect">
             <a:avLst/>
@@ -3831,132 +3979,29 @@
               </a:lnSpc>
             </a:pPr>
             <a:r>
-              <a:rPr sz="950" b="1">
-                <a:solidFill>
-                  <a:srgbClr val="86868B"/>
+              <a:rPr sz="3800" b="1">
+                <a:solidFill>
+                  <a:srgbClr val="0071E3"/>
                 </a:solidFill>
                 <a:latin typeface="PingFang SC"/>
                 <a:ea typeface="PingFang SC"/>
                 <a:cs typeface="PingFang SC"/>
               </a:rPr>
-              <a:t>MEDIA</a:t>
-            </a:r>
-          </a:p>
-        </p:txBody>
-      </p:sp>
-      <p:sp>
-        <p:nvSpPr>
-          <p:cNvPr id="18" name="Rounded Rectangle 17"/>
-          <p:cNvSpPr/>
-          <p:nvPr/>
-        </p:nvSpPr>
-        <p:spPr>
-          <a:xfrm>
-            <a:off x="640080" y="4201668"/>
-            <a:ext cx="5029200" cy="402336"/>
-          </a:xfrm>
-          <a:prstGeom prst="roundRect">
-            <a:avLst>
-              <a:gd name="adj" fmla="val 22000"/>
-            </a:avLst>
-          </a:prstGeom>
-          <a:solidFill>
-            <a:srgbClr val="FFFFFF"/>
-          </a:solidFill>
-          <a:ln w="12700">
-            <a:solidFill>
-              <a:srgbClr val="D8DBE0"/>
-            </a:solidFill>
-          </a:ln>
-          <a:effectLst/>
-        </p:spPr>
-        <p:style>
-          <a:lnRef idx="1">
-            <a:schemeClr val="accent1"/>
-          </a:lnRef>
-          <a:fillRef idx="3">
-            <a:schemeClr val="accent1"/>
-          </a:fillRef>
-          <a:effectRef idx="2">
-            <a:schemeClr val="accent1"/>
-          </a:effectRef>
-          <a:fontRef idx="minor">
-            <a:schemeClr val="lt1"/>
-          </a:fontRef>
-        </p:style>
-        <p:txBody>
-          <a:bodyPr rtlCol="0" anchor="ctr" wrap="square" lIns="164592" rIns="54864" tIns="18288" bIns="18288"/>
-          <a:lstStyle/>
-          <a:p>
-            <a:pPr algn="l"/>
-            <a:r>
-              <a:rPr sz="1300" b="1">
-                <a:solidFill>
-                  <a:srgbClr val="1D1D1F"/>
-                </a:solidFill>
-                <a:latin typeface="PingFang SC"/>
-                <a:ea typeface="PingFang SC"/>
-                <a:cs typeface="PingFang SC"/>
-              </a:rPr>
-              <a:t>Buffer Task A</a:t>
-            </a:r>
-          </a:p>
-        </p:txBody>
-      </p:sp>
-      <p:sp>
-        <p:nvSpPr>
-          <p:cNvPr id="19" name="Oval 18"/>
-          <p:cNvSpPr/>
-          <p:nvPr/>
-        </p:nvSpPr>
-        <p:spPr>
-          <a:xfrm>
-            <a:off x="4434840" y="4357116"/>
-            <a:ext cx="91440" cy="91440"/>
-          </a:xfrm>
-          <a:prstGeom prst="ellipse">
-            <a:avLst/>
-          </a:prstGeom>
-          <a:solidFill>
-            <a:srgbClr val="0A9D92"/>
-          </a:solidFill>
-          <a:ln>
-            <a:noFill/>
-          </a:ln>
-          <a:effectLst/>
-        </p:spPr>
-        <p:style>
-          <a:lnRef idx="1">
-            <a:schemeClr val="accent1"/>
-          </a:lnRef>
-          <a:fillRef idx="3">
-            <a:schemeClr val="accent1"/>
-          </a:fillRef>
-          <a:effectRef idx="2">
-            <a:schemeClr val="accent1"/>
-          </a:effectRef>
-          <a:fontRef idx="minor">
-            <a:schemeClr val="lt1"/>
-          </a:fontRef>
-        </p:style>
-        <p:txBody>
-          <a:bodyPr rtlCol="0" anchor="ctr"/>
-          <a:lstStyle/>
-          <a:p>
-            <a:pPr algn="ctr"/>
-          </a:p>
-        </p:txBody>
-      </p:sp>
-      <p:sp>
-        <p:nvSpPr>
-          <p:cNvPr id="20" name="TextBox 19"/>
+              <a:t>4 h</a:t>
+            </a:r>
+          </a:p>
+        </p:txBody>
+      </p:sp>
+      <p:sp>
+        <p:nvSpPr>
+          <p:cNvPr id="21" name="TextBox 20"/>
           <p:cNvSpPr txBox="1"/>
           <p:nvPr/>
         </p:nvSpPr>
         <p:spPr>
           <a:xfrm>
-            <a:off x="4590288" y="4279392"/>
-            <a:ext cx="960120" cy="256032"/>
+            <a:off x="640080" y="4773168"/>
+            <a:ext cx="4114800" cy="320040"/>
           </a:xfrm>
           <a:prstGeom prst="rect">
             <a:avLst/>
@@ -3975,33 +4020,33 @@
               </a:lnSpc>
             </a:pPr>
             <a:r>
-              <a:rPr sz="950" b="1">
-                <a:solidFill>
-                  <a:srgbClr val="86868B"/>
+              <a:rPr sz="1200" b="0">
+                <a:solidFill>
+                  <a:srgbClr val="515154"/>
                 </a:solidFill>
                 <a:latin typeface="PingFang SC"/>
                 <a:ea typeface="PingFang SC"/>
                 <a:cs typeface="PingFang SC"/>
               </a:rPr>
-              <a:t>BUFFER</a:t>
-            </a:r>
-          </a:p>
-        </p:txBody>
-      </p:sp>
-      <p:sp>
-        <p:nvSpPr>
-          <p:cNvPr id="21" name="Rounded Rectangle 20"/>
-          <p:cNvSpPr/>
-          <p:nvPr/>
-        </p:nvSpPr>
-        <p:spPr>
-          <a:xfrm>
-            <a:off x="640080" y="4700016"/>
-            <a:ext cx="5029200" cy="402336"/>
+              <a:t>完整建模一个部门全工艺</a:t>
+            </a:r>
+          </a:p>
+        </p:txBody>
+      </p:sp>
+      <p:sp>
+        <p:nvSpPr>
+          <p:cNvPr id="22" name="Rounded Rectangle 21"/>
+          <p:cNvSpPr/>
+          <p:nvPr/>
+        </p:nvSpPr>
+        <p:spPr>
+          <a:xfrm>
+            <a:off x="6217920" y="1280160"/>
+            <a:ext cx="5577840" cy="3520440"/>
           </a:xfrm>
           <a:prstGeom prst="roundRect">
             <a:avLst>
-              <a:gd name="adj" fmla="val 22000"/>
+              <a:gd name="adj" fmla="val 4000"/>
             </a:avLst>
           </a:prstGeom>
           <a:solidFill>
@@ -4029,582 +4074,6 @@
           </a:fontRef>
         </p:style>
         <p:txBody>
-          <a:bodyPr rtlCol="0" anchor="ctr" wrap="square" lIns="164592" rIns="54864" tIns="18288" bIns="18288"/>
-          <a:lstStyle/>
-          <a:p>
-            <a:pPr algn="l"/>
-            <a:r>
-              <a:rPr sz="1300" b="1">
-                <a:solidFill>
-                  <a:srgbClr val="1D1D1F"/>
-                </a:solidFill>
-                <a:latin typeface="PingFang SC"/>
-                <a:ea typeface="PingFang SC"/>
-                <a:cs typeface="PingFang SC"/>
-              </a:rPr>
-              <a:t>USP Task A</a:t>
-            </a:r>
-          </a:p>
-        </p:txBody>
-      </p:sp>
-      <p:sp>
-        <p:nvSpPr>
-          <p:cNvPr id="22" name="Oval 21"/>
-          <p:cNvSpPr/>
-          <p:nvPr/>
-        </p:nvSpPr>
-        <p:spPr>
-          <a:xfrm>
-            <a:off x="4434840" y="4855464"/>
-            <a:ext cx="91440" cy="91440"/>
-          </a:xfrm>
-          <a:prstGeom prst="ellipse">
-            <a:avLst/>
-          </a:prstGeom>
-          <a:solidFill>
-            <a:srgbClr val="0071E3"/>
-          </a:solidFill>
-          <a:ln>
-            <a:noFill/>
-          </a:ln>
-          <a:effectLst/>
-        </p:spPr>
-        <p:style>
-          <a:lnRef idx="1">
-            <a:schemeClr val="accent1"/>
-          </a:lnRef>
-          <a:fillRef idx="3">
-            <a:schemeClr val="accent1"/>
-          </a:fillRef>
-          <a:effectRef idx="2">
-            <a:schemeClr val="accent1"/>
-          </a:effectRef>
-          <a:fontRef idx="minor">
-            <a:schemeClr val="lt1"/>
-          </a:fontRef>
-        </p:style>
-        <p:txBody>
-          <a:bodyPr rtlCol="0" anchor="ctr"/>
-          <a:lstStyle/>
-          <a:p>
-            <a:pPr algn="ctr"/>
-          </a:p>
-        </p:txBody>
-      </p:sp>
-      <p:sp>
-        <p:nvSpPr>
-          <p:cNvPr id="23" name="TextBox 22"/>
-          <p:cNvSpPr txBox="1"/>
-          <p:nvPr/>
-        </p:nvSpPr>
-        <p:spPr>
-          <a:xfrm>
-            <a:off x="4590288" y="4777740"/>
-            <a:ext cx="960120" cy="256032"/>
-          </a:xfrm>
-          <a:prstGeom prst="rect">
-            <a:avLst/>
-          </a:prstGeom>
-          <a:noFill/>
-        </p:spPr>
-        <p:txBody>
-          <a:bodyPr wrap="square" anchor="t" lIns="0" rIns="0" tIns="0" bIns="0">
-            <a:spAutoFit/>
-          </a:bodyPr>
-          <a:lstStyle/>
-          <a:p>
-            <a:pPr algn="l">
-              <a:lnSpc>
-                <a:spcPct val="105000"/>
-              </a:lnSpc>
-            </a:pPr>
-            <a:r>
-              <a:rPr sz="950" b="1">
-                <a:solidFill>
-                  <a:srgbClr val="86868B"/>
-                </a:solidFill>
-                <a:latin typeface="PingFang SC"/>
-                <a:ea typeface="PingFang SC"/>
-                <a:cs typeface="PingFang SC"/>
-              </a:rPr>
-              <a:t>上游</a:t>
-            </a:r>
-          </a:p>
-        </p:txBody>
-      </p:sp>
-      <p:sp>
-        <p:nvSpPr>
-          <p:cNvPr id="24" name="Rounded Rectangle 23"/>
-          <p:cNvSpPr/>
-          <p:nvPr/>
-        </p:nvSpPr>
-        <p:spPr>
-          <a:xfrm>
-            <a:off x="640080" y="5198364"/>
-            <a:ext cx="5029200" cy="402336"/>
-          </a:xfrm>
-          <a:prstGeom prst="roundRect">
-            <a:avLst>
-              <a:gd name="adj" fmla="val 22000"/>
-            </a:avLst>
-          </a:prstGeom>
-          <a:solidFill>
-            <a:srgbClr val="FFFFFF"/>
-          </a:solidFill>
-          <a:ln w="12700">
-            <a:solidFill>
-              <a:srgbClr val="D8DBE0"/>
-            </a:solidFill>
-          </a:ln>
-          <a:effectLst/>
-        </p:spPr>
-        <p:style>
-          <a:lnRef idx="1">
-            <a:schemeClr val="accent1"/>
-          </a:lnRef>
-          <a:fillRef idx="3">
-            <a:schemeClr val="accent1"/>
-          </a:fillRef>
-          <a:effectRef idx="2">
-            <a:schemeClr val="accent1"/>
-          </a:effectRef>
-          <a:fontRef idx="minor">
-            <a:schemeClr val="lt1"/>
-          </a:fontRef>
-        </p:style>
-        <p:txBody>
-          <a:bodyPr rtlCol="0" anchor="ctr" wrap="square" lIns="164592" rIns="54864" tIns="18288" bIns="18288"/>
-          <a:lstStyle/>
-          <a:p>
-            <a:pPr algn="l"/>
-            <a:r>
-              <a:rPr sz="1300" b="1">
-                <a:solidFill>
-                  <a:srgbClr val="1D1D1F"/>
-                </a:solidFill>
-                <a:latin typeface="PingFang SC"/>
-                <a:ea typeface="PingFang SC"/>
-                <a:cs typeface="PingFang SC"/>
-              </a:rPr>
-              <a:t>USP Task B</a:t>
-            </a:r>
-          </a:p>
-        </p:txBody>
-      </p:sp>
-      <p:sp>
-        <p:nvSpPr>
-          <p:cNvPr id="25" name="Oval 24"/>
-          <p:cNvSpPr/>
-          <p:nvPr/>
-        </p:nvSpPr>
-        <p:spPr>
-          <a:xfrm>
-            <a:off x="4434840" y="5353812"/>
-            <a:ext cx="91440" cy="91440"/>
-          </a:xfrm>
-          <a:prstGeom prst="ellipse">
-            <a:avLst/>
-          </a:prstGeom>
-          <a:solidFill>
-            <a:srgbClr val="0071E3"/>
-          </a:solidFill>
-          <a:ln>
-            <a:noFill/>
-          </a:ln>
-          <a:effectLst/>
-        </p:spPr>
-        <p:style>
-          <a:lnRef idx="1">
-            <a:schemeClr val="accent1"/>
-          </a:lnRef>
-          <a:fillRef idx="3">
-            <a:schemeClr val="accent1"/>
-          </a:fillRef>
-          <a:effectRef idx="2">
-            <a:schemeClr val="accent1"/>
-          </a:effectRef>
-          <a:fontRef idx="minor">
-            <a:schemeClr val="lt1"/>
-          </a:fontRef>
-        </p:style>
-        <p:txBody>
-          <a:bodyPr rtlCol="0" anchor="ctr"/>
-          <a:lstStyle/>
-          <a:p>
-            <a:pPr algn="ctr"/>
-          </a:p>
-        </p:txBody>
-      </p:sp>
-      <p:sp>
-        <p:nvSpPr>
-          <p:cNvPr id="26" name="TextBox 25"/>
-          <p:cNvSpPr txBox="1"/>
-          <p:nvPr/>
-        </p:nvSpPr>
-        <p:spPr>
-          <a:xfrm>
-            <a:off x="4590288" y="5276088"/>
-            <a:ext cx="960120" cy="256032"/>
-          </a:xfrm>
-          <a:prstGeom prst="rect">
-            <a:avLst/>
-          </a:prstGeom>
-          <a:noFill/>
-        </p:spPr>
-        <p:txBody>
-          <a:bodyPr wrap="square" anchor="t" lIns="0" rIns="0" tIns="0" bIns="0">
-            <a:spAutoFit/>
-          </a:bodyPr>
-          <a:lstStyle/>
-          <a:p>
-            <a:pPr algn="l">
-              <a:lnSpc>
-                <a:spcPct val="105000"/>
-              </a:lnSpc>
-            </a:pPr>
-            <a:r>
-              <a:rPr sz="950" b="1">
-                <a:solidFill>
-                  <a:srgbClr val="86868B"/>
-                </a:solidFill>
-                <a:latin typeface="PingFang SC"/>
-                <a:ea typeface="PingFang SC"/>
-                <a:cs typeface="PingFang SC"/>
-              </a:rPr>
-              <a:t>上游</a:t>
-            </a:r>
-          </a:p>
-        </p:txBody>
-      </p:sp>
-      <p:sp>
-        <p:nvSpPr>
-          <p:cNvPr id="27" name="Rounded Rectangle 26"/>
-          <p:cNvSpPr/>
-          <p:nvPr/>
-        </p:nvSpPr>
-        <p:spPr>
-          <a:xfrm>
-            <a:off x="640080" y="5696712"/>
-            <a:ext cx="5029200" cy="402336"/>
-          </a:xfrm>
-          <a:prstGeom prst="roundRect">
-            <a:avLst>
-              <a:gd name="adj" fmla="val 22000"/>
-            </a:avLst>
-          </a:prstGeom>
-          <a:solidFill>
-            <a:srgbClr val="FFFFFF"/>
-          </a:solidFill>
-          <a:ln w="12700">
-            <a:solidFill>
-              <a:srgbClr val="D8DBE0"/>
-            </a:solidFill>
-          </a:ln>
-          <a:effectLst/>
-        </p:spPr>
-        <p:style>
-          <a:lnRef idx="1">
-            <a:schemeClr val="accent1"/>
-          </a:lnRef>
-          <a:fillRef idx="3">
-            <a:schemeClr val="accent1"/>
-          </a:fillRef>
-          <a:effectRef idx="2">
-            <a:schemeClr val="accent1"/>
-          </a:effectRef>
-          <a:fontRef idx="minor">
-            <a:schemeClr val="lt1"/>
-          </a:fontRef>
-        </p:style>
-        <p:txBody>
-          <a:bodyPr rtlCol="0" anchor="ctr" wrap="square" lIns="164592" rIns="54864" tIns="18288" bIns="18288"/>
-          <a:lstStyle/>
-          <a:p>
-            <a:pPr algn="l"/>
-            <a:r>
-              <a:rPr sz="1300" b="1">
-                <a:solidFill>
-                  <a:srgbClr val="1D1D1F"/>
-                </a:solidFill>
-                <a:latin typeface="PingFang SC"/>
-                <a:ea typeface="PingFang SC"/>
-                <a:cs typeface="PingFang SC"/>
-              </a:rPr>
-              <a:t>DSP Task A</a:t>
-            </a:r>
-          </a:p>
-        </p:txBody>
-      </p:sp>
-      <p:sp>
-        <p:nvSpPr>
-          <p:cNvPr id="28" name="Oval 27"/>
-          <p:cNvSpPr/>
-          <p:nvPr/>
-        </p:nvSpPr>
-        <p:spPr>
-          <a:xfrm>
-            <a:off x="4434840" y="5852159"/>
-            <a:ext cx="91440" cy="91440"/>
-          </a:xfrm>
-          <a:prstGeom prst="ellipse">
-            <a:avLst/>
-          </a:prstGeom>
-          <a:solidFill>
-            <a:srgbClr val="34A06B"/>
-          </a:solidFill>
-          <a:ln>
-            <a:noFill/>
-          </a:ln>
-          <a:effectLst/>
-        </p:spPr>
-        <p:style>
-          <a:lnRef idx="1">
-            <a:schemeClr val="accent1"/>
-          </a:lnRef>
-          <a:fillRef idx="3">
-            <a:schemeClr val="accent1"/>
-          </a:fillRef>
-          <a:effectRef idx="2">
-            <a:schemeClr val="accent1"/>
-          </a:effectRef>
-          <a:fontRef idx="minor">
-            <a:schemeClr val="lt1"/>
-          </a:fontRef>
-        </p:style>
-        <p:txBody>
-          <a:bodyPr rtlCol="0" anchor="ctr"/>
-          <a:lstStyle/>
-          <a:p>
-            <a:pPr algn="ctr"/>
-          </a:p>
-        </p:txBody>
-      </p:sp>
-      <p:sp>
-        <p:nvSpPr>
-          <p:cNvPr id="29" name="TextBox 28"/>
-          <p:cNvSpPr txBox="1"/>
-          <p:nvPr/>
-        </p:nvSpPr>
-        <p:spPr>
-          <a:xfrm>
-            <a:off x="4590288" y="5774436"/>
-            <a:ext cx="960120" cy="256032"/>
-          </a:xfrm>
-          <a:prstGeom prst="rect">
-            <a:avLst/>
-          </a:prstGeom>
-          <a:noFill/>
-        </p:spPr>
-        <p:txBody>
-          <a:bodyPr wrap="square" anchor="t" lIns="0" rIns="0" tIns="0" bIns="0">
-            <a:spAutoFit/>
-          </a:bodyPr>
-          <a:lstStyle/>
-          <a:p>
-            <a:pPr algn="l">
-              <a:lnSpc>
-                <a:spcPct val="105000"/>
-              </a:lnSpc>
-            </a:pPr>
-            <a:r>
-              <a:rPr sz="950" b="1">
-                <a:solidFill>
-                  <a:srgbClr val="86868B"/>
-                </a:solidFill>
-                <a:latin typeface="PingFang SC"/>
-                <a:ea typeface="PingFang SC"/>
-                <a:cs typeface="PingFang SC"/>
-              </a:rPr>
-              <a:t>下游</a:t>
-            </a:r>
-          </a:p>
-        </p:txBody>
-      </p:sp>
-      <p:sp>
-        <p:nvSpPr>
-          <p:cNvPr id="30" name="Rounded Rectangle 29"/>
-          <p:cNvSpPr/>
-          <p:nvPr/>
-        </p:nvSpPr>
-        <p:spPr>
-          <a:xfrm>
-            <a:off x="640080" y="6195059"/>
-            <a:ext cx="5029200" cy="402336"/>
-          </a:xfrm>
-          <a:prstGeom prst="roundRect">
-            <a:avLst>
-              <a:gd name="adj" fmla="val 22000"/>
-            </a:avLst>
-          </a:prstGeom>
-          <a:solidFill>
-            <a:srgbClr val="FFFFFF"/>
-          </a:solidFill>
-          <a:ln w="12700">
-            <a:solidFill>
-              <a:srgbClr val="D8DBE0"/>
-            </a:solidFill>
-          </a:ln>
-          <a:effectLst/>
-        </p:spPr>
-        <p:style>
-          <a:lnRef idx="1">
-            <a:schemeClr val="accent1"/>
-          </a:lnRef>
-          <a:fillRef idx="3">
-            <a:schemeClr val="accent1"/>
-          </a:fillRef>
-          <a:effectRef idx="2">
-            <a:schemeClr val="accent1"/>
-          </a:effectRef>
-          <a:fontRef idx="minor">
-            <a:schemeClr val="lt1"/>
-          </a:fontRef>
-        </p:style>
-        <p:txBody>
-          <a:bodyPr rtlCol="0" anchor="ctr" wrap="square" lIns="164592" rIns="54864" tIns="18288" bIns="18288"/>
-          <a:lstStyle/>
-          <a:p>
-            <a:pPr algn="l"/>
-            <a:r>
-              <a:rPr sz="1300" b="1">
-                <a:solidFill>
-                  <a:srgbClr val="1D1D1F"/>
-                </a:solidFill>
-                <a:latin typeface="PingFang SC"/>
-                <a:ea typeface="PingFang SC"/>
-                <a:cs typeface="PingFang SC"/>
-              </a:rPr>
-              <a:t>DSP Task B</a:t>
-            </a:r>
-          </a:p>
-        </p:txBody>
-      </p:sp>
-      <p:sp>
-        <p:nvSpPr>
-          <p:cNvPr id="31" name="Oval 30"/>
-          <p:cNvSpPr/>
-          <p:nvPr/>
-        </p:nvSpPr>
-        <p:spPr>
-          <a:xfrm>
-            <a:off x="4434840" y="6350507"/>
-            <a:ext cx="91440" cy="91440"/>
-          </a:xfrm>
-          <a:prstGeom prst="ellipse">
-            <a:avLst/>
-          </a:prstGeom>
-          <a:solidFill>
-            <a:srgbClr val="34A06B"/>
-          </a:solidFill>
-          <a:ln>
-            <a:noFill/>
-          </a:ln>
-          <a:effectLst/>
-        </p:spPr>
-        <p:style>
-          <a:lnRef idx="1">
-            <a:schemeClr val="accent1"/>
-          </a:lnRef>
-          <a:fillRef idx="3">
-            <a:schemeClr val="accent1"/>
-          </a:fillRef>
-          <a:effectRef idx="2">
-            <a:schemeClr val="accent1"/>
-          </a:effectRef>
-          <a:fontRef idx="minor">
-            <a:schemeClr val="lt1"/>
-          </a:fontRef>
-        </p:style>
-        <p:txBody>
-          <a:bodyPr rtlCol="0" anchor="ctr"/>
-          <a:lstStyle/>
-          <a:p>
-            <a:pPr algn="ctr"/>
-          </a:p>
-        </p:txBody>
-      </p:sp>
-      <p:sp>
-        <p:nvSpPr>
-          <p:cNvPr id="32" name="TextBox 31"/>
-          <p:cNvSpPr txBox="1"/>
-          <p:nvPr/>
-        </p:nvSpPr>
-        <p:spPr>
-          <a:xfrm>
-            <a:off x="4590288" y="6272783"/>
-            <a:ext cx="960120" cy="256032"/>
-          </a:xfrm>
-          <a:prstGeom prst="rect">
-            <a:avLst/>
-          </a:prstGeom>
-          <a:noFill/>
-        </p:spPr>
-        <p:txBody>
-          <a:bodyPr wrap="square" anchor="t" lIns="0" rIns="0" tIns="0" bIns="0">
-            <a:spAutoFit/>
-          </a:bodyPr>
-          <a:lstStyle/>
-          <a:p>
-            <a:pPr algn="l">
-              <a:lnSpc>
-                <a:spcPct val="105000"/>
-              </a:lnSpc>
-            </a:pPr>
-            <a:r>
-              <a:rPr sz="950" b="1">
-                <a:solidFill>
-                  <a:srgbClr val="86868B"/>
-                </a:solidFill>
-                <a:latin typeface="PingFang SC"/>
-                <a:ea typeface="PingFang SC"/>
-                <a:cs typeface="PingFang SC"/>
-              </a:rPr>
-              <a:t>下游</a:t>
-            </a:r>
-          </a:p>
-        </p:txBody>
-      </p:sp>
-      <p:sp>
-        <p:nvSpPr>
-          <p:cNvPr id="33" name="Rounded Rectangle 32"/>
-          <p:cNvSpPr/>
-          <p:nvPr/>
-        </p:nvSpPr>
-        <p:spPr>
-          <a:xfrm>
-            <a:off x="6217920" y="1280160"/>
-            <a:ext cx="5577840" cy="3520440"/>
-          </a:xfrm>
-          <a:prstGeom prst="roundRect">
-            <a:avLst>
-              <a:gd name="adj" fmla="val 4000"/>
-            </a:avLst>
-          </a:prstGeom>
-          <a:solidFill>
-            <a:srgbClr val="FFFFFF"/>
-          </a:solidFill>
-          <a:ln w="12700">
-            <a:solidFill>
-              <a:srgbClr val="D8DBE0"/>
-            </a:solidFill>
-          </a:ln>
-          <a:effectLst/>
-        </p:spPr>
-        <p:style>
-          <a:lnRef idx="1">
-            <a:schemeClr val="accent1"/>
-          </a:lnRef>
-          <a:fillRef idx="3">
-            <a:schemeClr val="accent1"/>
-          </a:fillRef>
-          <a:effectRef idx="2">
-            <a:schemeClr val="accent1"/>
-          </a:effectRef>
-          <a:fontRef idx="minor">
-            <a:schemeClr val="lt1"/>
-          </a:fontRef>
-        </p:style>
-        <p:txBody>
           <a:bodyPr rtlCol="0" anchor="ctr" wrap="square"/>
           <a:lstStyle/>
           <a:p>
@@ -4614,7 +4083,7 @@
       </p:sp>
       <p:pic>
         <p:nvPicPr>
-          <p:cNvPr id="34" name="Picture 33" descr="20_process_templates.png"/>
+          <p:cNvPr id="23" name="Picture 22" descr="20_process_templates.png"/>
           <p:cNvPicPr>
             <a:picLocks noChangeAspect="1"/>
           </p:cNvPicPr>
@@ -4638,7 +4107,7 @@
       </p:pic>
       <p:sp>
         <p:nvSpPr>
-          <p:cNvPr id="35" name="TextBox 34"/>
+          <p:cNvPr id="24" name="TextBox 23"/>
           <p:cNvSpPr txBox="1"/>
           <p:nvPr/>
         </p:nvSpPr>

</xml_diff>